<commit_message>
Captures et deck rafraichis en 0.9.1
Les numeros de version ne sont plus ecrits en dur : captures.mjs et
faire-deck.py les lisent dans package.json. La fenetre de mise a jour montre
donc le vrai saut, et la slide d installation le vrai nom de fichier.

Les recadrages passent dans scripts/recadrer.py, au lieu d etre refaits a la
main a chaque passe.

Co-Authored-By: Claude Opus 5 <noreply@anthropic.com>
</commit_message>
<xml_diff>
--- a/StreamKit_Presentation.pptx
+++ b/StreamKit_Presentation.pptx
@@ -3366,7 +3366,7 @@
                 </a:solidFill>
                 <a:latin typeface="Segoe UI"/>
               </a:rPr>
-              <a:t>0.9.0</a:t>
+              <a:t>0.9.1</a:t>
             </a:r>
           </a:p>
           <a:p>
@@ -15142,7 +15142,7 @@
                 </a:solidFill>
                 <a:latin typeface="Segoe UI"/>
               </a:rPr>
-              <a:t>Sur la page des versions du dépôt, prends le fichier StreamKit-Setup-0.9.0.exe (le plus récent).</a:t>
+              <a:t>Sur la page des versions du dépôt, prends le fichier StreamKit-Setup-0.9.1.exe (le plus récent).</a:t>
             </a:r>
           </a:p>
         </p:txBody>

</xml_diff>

<commit_message>
Captures et deck rafraichis apres le renommage
Le rail de la slide « Les modules » affichait encore Roue des voitures et
Bandeau de session.

Co-Authored-By: Claude Opus 5 <noreply@anthropic.com>
</commit_message>
<xml_diff>
--- a/StreamKit_Presentation.pptx
+++ b/StreamKit_Presentation.pptx
@@ -3366,7 +3366,7 @@
                 </a:solidFill>
                 <a:latin typeface="Segoe UI"/>
               </a:rPr>
-              <a:t>0.9.1</a:t>
+              <a:t>0.10.1</a:t>
             </a:r>
           </a:p>
           <a:p>
@@ -11714,7 +11714,7 @@
                 </a:solidFill>
                 <a:latin typeface="Segoe UI"/>
               </a:rPr>
-              <a:t>Roue des voitures</a:t>
+              <a:t>Random Car</a:t>
             </a:r>
           </a:p>
           <a:p>
@@ -11826,7 +11826,7 @@
                 </a:solidFill>
                 <a:latin typeface="Segoe UI"/>
               </a:rPr>
-              <a:t>Bandeau de session</a:t>
+              <a:t>Overlay W/L</a:t>
             </a:r>
           </a:p>
           <a:p>
@@ -15142,7 +15142,7 @@
                 </a:solidFill>
                 <a:latin typeface="Segoe UI"/>
               </a:rPr>
-              <a:t>Sur la page des versions du dépôt, prends le fichier StreamKit-Setup-0.9.1.exe (le plus récent).</a:t>
+              <a:t>Sur la page des versions du dépôt, prends le fichier StreamKit-Setup-0.10.1.exe (le plus récent).</a:t>
             </a:r>
           </a:p>
         </p:txBody>

</xml_diff>

<commit_message>
Fusionner l assistant Twitch dans l ecran Connecteurs
Deux formulaires demandaient la meme chose — nom de chaine, ID et secret
client — et ecrivaient au meme endroit : la fenetre ouverte par l indicateur
du bandeau, et la carte Twitch de l ecran Connecteurs. Les routes de la
premiere appelaient litteralement les fonctions de la seconde.

La fenetre disparait. L indicateur amene desormais sur l ecran Connecteurs
avec la carte Twitch depliee : le chemin d entree reste le meme, tous les
textes d aide qui disent « clique sur l indicateur Twitch » restent vrais,
et il n y a plus qu un seul endroit ou brancher un service.

Les routes /api/twitch/app, /chaine et /autoriser partent avec elle : plus
aucun appelant, et /api/connecteurs/twitch/... fait exactement la meme chose.

Deck : la slide de l etape 2 montrait la fenetre supprimee.

Co-Authored-By: Claude Opus 5 <noreply@anthropic.com>
</commit_message>
<xml_diff>
--- a/StreamKit_Presentation.pptx
+++ b/StreamKit_Presentation.pptx
@@ -3821,8 +3821,8 @@
         </p:nvSpPr>
         <p:spPr>
           <a:xfrm>
-            <a:off x="676800" y="2170800"/>
-            <a:ext cx="4772903" cy="4190400"/>
+            <a:off x="676800" y="2224800"/>
+            <a:ext cx="6206399" cy="3909280"/>
           </a:xfrm>
           <a:prstGeom prst="roundRect">
             <a:avLst>
@@ -3875,8 +3875,8 @@
         </p:blipFill>
         <p:spPr>
           <a:xfrm>
-            <a:off x="720000" y="2214000"/>
-            <a:ext cx="4686503" cy="4104000"/>
+            <a:off x="720000" y="2268000"/>
+            <a:ext cx="6120000" cy="3822880"/>
           </a:xfrm>
           <a:prstGeom prst="rect">
             <a:avLst/>
@@ -3891,7 +3891,7 @@
         </p:nvSpPr>
         <p:spPr>
           <a:xfrm>
-            <a:off x="5940000" y="2203199"/>
+            <a:off x="7272000" y="2221199"/>
             <a:ext cx="280800" cy="280800"/>
           </a:xfrm>
           <a:prstGeom prst="ellipse">
@@ -3954,8 +3954,8 @@
         </p:nvSpPr>
         <p:spPr>
           <a:xfrm>
-            <a:off x="6353999" y="2185200"/>
-            <a:ext cx="5118119" cy="702000"/>
+            <a:off x="7685999" y="2203199"/>
+            <a:ext cx="3786119" cy="702000"/>
           </a:xfrm>
           <a:prstGeom prst="rect">
             <a:avLst/>
@@ -4005,7 +4005,7 @@
                 </a:solidFill>
                 <a:latin typeface="Segoe UI"/>
               </a:rPr>
-              <a:t>Tout en haut de la fenêtre. L’assistant ci-contre s’ouvre.</a:t>
+              <a:t>En haut de la fenêtre. Il t’amène sur l’écran Connecteurs, carte Twitch ouverte.</a:t>
             </a:r>
           </a:p>
         </p:txBody>
@@ -4018,7 +4018,7 @@
         </p:nvSpPr>
         <p:spPr>
           <a:xfrm>
-            <a:off x="5940000" y="2905200"/>
+            <a:off x="7272000" y="2923199"/>
             <a:ext cx="280800" cy="280800"/>
           </a:xfrm>
           <a:prstGeom prst="ellipse">
@@ -4081,8 +4081,8 @@
         </p:nvSpPr>
         <p:spPr>
           <a:xfrm>
-            <a:off x="6353999" y="2887200"/>
-            <a:ext cx="5118119" cy="702000"/>
+            <a:off x="7685999" y="2905199"/>
+            <a:ext cx="3786119" cy="702000"/>
           </a:xfrm>
           <a:prstGeom prst="rect">
             <a:avLst/>
@@ -4132,7 +4132,7 @@
                 </a:solidFill>
                 <a:latin typeface="Segoe UI"/>
               </a:rPr>
-              <a:t>Le lien est dans l’assistant. C’est gratuit et ça ne demande que ton compte Twitch habituel.</a:t>
+              <a:t>Gratuit, avec ton compte Twitch habituel.</a:t>
             </a:r>
           </a:p>
         </p:txBody>
@@ -4145,7 +4145,7 @@
         </p:nvSpPr>
         <p:spPr>
           <a:xfrm>
-            <a:off x="5940000" y="3607200"/>
+            <a:off x="7272000" y="3625200"/>
             <a:ext cx="280800" cy="280800"/>
           </a:xfrm>
           <a:prstGeom prst="ellipse">
@@ -4208,8 +4208,8 @@
         </p:nvSpPr>
         <p:spPr>
           <a:xfrm>
-            <a:off x="6353999" y="3589199"/>
-            <a:ext cx="5118119" cy="702000"/>
+            <a:off x="7685999" y="3607200"/>
+            <a:ext cx="3786119" cy="702000"/>
           </a:xfrm>
           <a:prstGeom prst="rect">
             <a:avLst/>
@@ -4259,7 +4259,7 @@
                 </a:solidFill>
                 <a:latin typeface="Segoe UI"/>
               </a:rPr>
-              <a:t>Nom : StreamKit. Catégorie : Chat Bot. Les deux sont libres, mais autant s’y retrouver plus tard.</a:t>
+              <a:t>Nom : StreamKit. Catégorie : Chat Bot.</a:t>
             </a:r>
           </a:p>
         </p:txBody>
@@ -4272,7 +4272,7 @@
         </p:nvSpPr>
         <p:spPr>
           <a:xfrm>
-            <a:off x="5940000" y="4309200"/>
+            <a:off x="7272000" y="4327200"/>
             <a:ext cx="280800" cy="280800"/>
           </a:xfrm>
           <a:prstGeom prst="ellipse">
@@ -4335,8 +4335,8 @@
         </p:nvSpPr>
         <p:spPr>
           <a:xfrm>
-            <a:off x="6353999" y="4291200"/>
-            <a:ext cx="5118119" cy="702000"/>
+            <a:off x="7685999" y="4309200"/>
+            <a:ext cx="3786119" cy="702000"/>
           </a:xfrm>
           <a:prstGeom prst="rect">
             <a:avLst/>
@@ -4364,7 +4364,7 @@
                 </a:solidFill>
                 <a:latin typeface="Segoe UI"/>
               </a:rPr>
-              <a:t>Colle l’URL de redirection affichée</a:t>
+              <a:t>Colle l’adresse de retour affichée</a:t>
             </a:r>
           </a:p>
           <a:p>
@@ -4386,7 +4386,7 @@
                 </a:solidFill>
                 <a:latin typeface="Segoe UI"/>
               </a:rPr>
-              <a:t>http://localhost:4455/callback/twitch — au caractère près. C’est la cause numéro un des échecs d’autorisation.</a:t>
+              <a:t>Au caractère près : c’est la cause numéro un des refus d’autorisation.</a:t>
             </a:r>
           </a:p>
         </p:txBody>
@@ -4399,7 +4399,7 @@
         </p:nvSpPr>
         <p:spPr>
           <a:xfrm>
-            <a:off x="5940000" y="5011200"/>
+            <a:off x="7272000" y="5029200"/>
             <a:ext cx="280800" cy="280800"/>
           </a:xfrm>
           <a:prstGeom prst="ellipse">
@@ -4462,8 +4462,8 @@
         </p:nvSpPr>
         <p:spPr>
           <a:xfrm>
-            <a:off x="6353999" y="4993200"/>
-            <a:ext cx="5118119" cy="702000"/>
+            <a:off x="7685999" y="5011200"/>
+            <a:ext cx="3786119" cy="702000"/>
           </a:xfrm>
           <a:prstGeom prst="rect">
             <a:avLst/>
@@ -4491,7 +4491,7 @@
                 </a:solidFill>
                 <a:latin typeface="Segoe UI"/>
               </a:rPr>
-              <a:t>Récupère l’ID et le secret client</a:t>
+              <a:t>Renseigne chaîne, ID et secret</a:t>
             </a:r>
           </a:p>
           <a:p>
@@ -4513,7 +4513,7 @@
                 </a:solidFill>
                 <a:latin typeface="Segoe UI"/>
               </a:rPr>
-              <a:t>Colle-les avec le nom de ta chaîne, puis « Enregistrer et autoriser ».</a:t>
+              <a:t>Puis « Enregistrer ».</a:t>
             </a:r>
           </a:p>
         </p:txBody>
@@ -4526,7 +4526,7 @@
         </p:nvSpPr>
         <p:spPr>
           <a:xfrm>
-            <a:off x="5940000" y="5713200"/>
+            <a:off x="7272000" y="5731200"/>
             <a:ext cx="280800" cy="280800"/>
           </a:xfrm>
           <a:prstGeom prst="ellipse">
@@ -4589,8 +4589,8 @@
         </p:nvSpPr>
         <p:spPr>
           <a:xfrm>
-            <a:off x="6353999" y="5695199"/>
-            <a:ext cx="5118119" cy="702000"/>
+            <a:off x="7685999" y="5713200"/>
+            <a:ext cx="3786119" cy="702000"/>
           </a:xfrm>
           <a:prstGeom prst="rect">
             <a:avLst/>
@@ -4618,7 +4618,7 @@
                 </a:solidFill>
                 <a:latin typeface="Segoe UI"/>
               </a:rPr>
-              <a:t>Autorise dans le navigateur</a:t>
+              <a:t>Clique sur « Connecter »</a:t>
             </a:r>
           </a:p>
           <a:p>
@@ -4640,7 +4640,7 @@
                 </a:solidFill>
                 <a:latin typeface="Segoe UI"/>
               </a:rPr>
-              <a:t>Une page Twitch s’ouvre. Tu cliques sur Autoriser, tu reviens : l’indicateur est passé au vert.</a:t>
+              <a:t>Une page Twitch s’ouvre : Autoriser. L’indicateur passe au vert.</a:t>
             </a:r>
           </a:p>
         </p:txBody>

</xml_diff>